<commit_message>
Polish final landing and deck rendering
- landing.html: no empty gallery slots with a single photo, model not repeated under the name, headline not repeated
  in the hero paragraph, breadcrumb without duplicate collection, long stat values in readable type, mixed-direction
  values bidi-isolated (bdi), sales cheat sheet in two columns
- launch.pptx: the template's shrink-on-overflow autofit applied deterministically (presentation.render.shrink_to_fit,
  floor 55% / 8 pt); PRESENTATION_TEXT_FIT notes, overflow warnings only when the floor is still too large
- tests: shrink_to_fit unit tests; thumbnail-strip expectation updated (320 total)
- gessi-jacqueline-77201 re-rendered

Co-Authored-By: Claude Fable 5.1 <noreply@anthropic.com>
</commit_message>
<xml_diff>
--- a/out/gessi-jacqueline-77201/launch.pptx
+++ b/out/gessi-jacqueline-77201/launch.pptx
@@ -1494,7 +1494,7 @@
               <a:buNone/>
             </a:pPr>
             <a:r>
-              <a:rPr lang="en-US" sz="1250" dirty="0">
+              <a:rPr lang="en-US" sz="850" dirty="0">
                 <a:solidFill>
                   <a:srgbClr val="F2F2F2"/>
                 </a:solidFill>
@@ -1534,7 +1534,7 @@
               <a:buNone/>
             </a:pPr>
             <a:r>
-              <a:rPr lang="en-US" sz="1100" dirty="0">
+              <a:rPr lang="en-US" sz="1000" dirty="0">
                 <a:solidFill>
                   <a:srgbClr val="BDBDBD"/>
                 </a:solidFill>
@@ -2080,7 +2080,7 @@
               <a:buNone/>
             </a:pPr>
             <a:r>
-              <a:rPr lang="en-US" sz="1650" dirty="0" b="1">
+              <a:rPr lang="en-US" sz="1600" dirty="0" b="1">
                 <a:solidFill>
                   <a:srgbClr val="F2F2F2"/>
                 </a:solidFill>
@@ -2091,7 +2091,7 @@
               <a:t>מוצר: </a:t>
             </a:r>
             <a:r>
-              <a:rPr lang="en-US" sz="1650" dirty="0">
+              <a:rPr lang="en-US" sz="1600" dirty="0">
                 <a:solidFill>
                   <a:srgbClr val="F2F2F2"/>
                 </a:solidFill>
@@ -2107,7 +2107,7 @@
               <a:buNone/>
             </a:pPr>
             <a:r>
-              <a:rPr lang="en-US" sz="1650" dirty="0" b="1">
+              <a:rPr lang="en-US" sz="1600" dirty="0" b="1">
                 <a:solidFill>
                   <a:srgbClr val="F2F2F2"/>
                 </a:solidFill>
@@ -2118,7 +2118,7 @@
               <a:t>מותג / קולקציה: </a:t>
             </a:r>
             <a:r>
-              <a:rPr lang="en-US" sz="1650" dirty="0">
+              <a:rPr lang="en-US" sz="1600" dirty="0">
                 <a:solidFill>
                   <a:srgbClr val="F2F2F2"/>
                 </a:solidFill>
@@ -2134,7 +2134,7 @@
               <a:buNone/>
             </a:pPr>
             <a:r>
-              <a:rPr lang="en-US" sz="1650" dirty="0" b="1">
+              <a:rPr lang="en-US" sz="1600" dirty="0" b="1">
                 <a:solidFill>
                   <a:srgbClr val="F2F2F2"/>
                 </a:solidFill>
@@ -2145,7 +2145,7 @@
               <a:t>קטגוריה: </a:t>
             </a:r>
             <a:r>
-              <a:rPr lang="en-US" sz="1650" dirty="0">
+              <a:rPr lang="en-US" sz="1600" dirty="0">
                 <a:solidFill>
                   <a:srgbClr val="F2F2F2"/>
                 </a:solidFill>
@@ -2161,7 +2161,7 @@
               <a:buNone/>
             </a:pPr>
             <a:r>
-              <a:rPr lang="en-US" sz="1650" dirty="0" b="1">
+              <a:rPr lang="en-US" sz="1600" dirty="0" b="1">
                 <a:solidFill>
                   <a:srgbClr val="F2F2F2"/>
                 </a:solidFill>
@@ -2172,7 +2172,7 @@
               <a:t>מק"ט: </a:t>
             </a:r>
             <a:r>
-              <a:rPr lang="en-US" sz="1650" dirty="0">
+              <a:rPr lang="en-US" sz="1600" dirty="0">
                 <a:solidFill>
                   <a:srgbClr val="F2F2F2"/>
                 </a:solidFill>
@@ -2253,7 +2253,7 @@
               <a:buNone/>
             </a:pPr>
             <a:r>
-              <a:rPr lang="en-US" sz="1550" dirty="0">
+              <a:rPr lang="en-US" sz="950" dirty="0">
                 <a:solidFill>
                   <a:srgbClr val="F2F2F2"/>
                 </a:solidFill>
@@ -2269,7 +2269,7 @@
               <a:buNone/>
             </a:pPr>
             <a:r>
-              <a:rPr lang="en-US" sz="1550" dirty="0">
+              <a:rPr lang="en-US" sz="950" dirty="0">
                 <a:solidFill>
                   <a:srgbClr val="F2F2F2"/>
                 </a:solidFill>
@@ -2285,7 +2285,7 @@
               <a:buNone/>
             </a:pPr>
             <a:r>
-              <a:rPr lang="en-US" sz="1550" dirty="0">
+              <a:rPr lang="en-US" sz="950" dirty="0">
                 <a:solidFill>
                   <a:srgbClr val="F2F2F2"/>
                 </a:solidFill>
@@ -2301,7 +2301,7 @@
               <a:buNone/>
             </a:pPr>
             <a:r>
-              <a:rPr lang="en-US" sz="1550" dirty="0">
+              <a:rPr lang="en-US" sz="950" dirty="0">
                 <a:solidFill>
                   <a:srgbClr val="F2F2F2"/>
                 </a:solidFill>
@@ -2317,7 +2317,7 @@
               <a:buNone/>
             </a:pPr>
             <a:r>
-              <a:rPr lang="en-US" sz="1550" dirty="0">
+              <a:rPr lang="en-US" sz="950" dirty="0">
                 <a:solidFill>
                   <a:srgbClr val="F2F2F2"/>
                 </a:solidFill>
@@ -2846,7 +2846,7 @@
               <a:buNone/>
             </a:pPr>
             <a:r>
-              <a:rPr lang="en-US" sz="1450" dirty="0">
+              <a:rPr lang="en-US" sz="1400" dirty="0">
                 <a:solidFill>
                   <a:srgbClr val="F2F2F2"/>
                 </a:solidFill>
@@ -3548,7 +3548,7 @@
               <a:buNone/>
             </a:pPr>
             <a:r>
-              <a:rPr lang="en-US" sz="1450" dirty="0">
+              <a:rPr lang="en-US" sz="950" dirty="0">
                 <a:solidFill>
                   <a:srgbClr val="F2F2F2"/>
                 </a:solidFill>
@@ -3564,7 +3564,7 @@
               <a:buNone/>
             </a:pPr>
             <a:r>
-              <a:rPr lang="en-US" sz="1450" dirty="0" b="1">
+              <a:rPr lang="en-US" sz="950" dirty="0" b="1">
                 <a:solidFill>
                   <a:srgbClr val="F2F2F2"/>
                 </a:solidFill>
@@ -3575,7 +3575,7 @@
               <a:t>• הצורך: </a:t>
             </a:r>
             <a:r>
-              <a:rPr lang="en-US" sz="1450" dirty="0">
+              <a:rPr lang="en-US" sz="950" dirty="0">
                 <a:solidFill>
                   <a:srgbClr val="F2F2F2"/>
                 </a:solidFill>
@@ -3591,7 +3591,7 @@
               <a:buNone/>
             </a:pPr>
             <a:r>
-              <a:rPr lang="en-US" sz="1450" dirty="0" b="1">
+              <a:rPr lang="en-US" sz="950" dirty="0" b="1">
                 <a:solidFill>
                   <a:srgbClr val="F2F2F2"/>
                 </a:solidFill>
@@ -3602,7 +3602,7 @@
               <a:t>• מה מכריע: </a:t>
             </a:r>
             <a:r>
-              <a:rPr lang="en-US" sz="1450" dirty="0">
+              <a:rPr lang="en-US" sz="950" dirty="0">
                 <a:solidFill>
                   <a:srgbClr val="F2F2F2"/>
                 </a:solidFill>
@@ -3683,7 +3683,7 @@
               <a:buNone/>
             </a:pPr>
             <a:r>
-              <a:rPr lang="en-US" sz="1450" dirty="0">
+              <a:rPr lang="en-US" sz="950" dirty="0">
                 <a:solidFill>
                   <a:srgbClr val="F2F2F2"/>
                 </a:solidFill>
@@ -3699,7 +3699,7 @@
               <a:buNone/>
             </a:pPr>
             <a:r>
-              <a:rPr lang="en-US" sz="1450" dirty="0" b="1">
+              <a:rPr lang="en-US" sz="950" dirty="0" b="1">
                 <a:solidFill>
                   <a:srgbClr val="F2F2F2"/>
                 </a:solidFill>
@@ -3710,7 +3710,7 @@
               <a:t>• הצורך: </a:t>
             </a:r>
             <a:r>
-              <a:rPr lang="en-US" sz="1450" dirty="0">
+              <a:rPr lang="en-US" sz="950" dirty="0">
                 <a:solidFill>
                   <a:srgbClr val="F2F2F2"/>
                 </a:solidFill>
@@ -3726,7 +3726,7 @@
               <a:buNone/>
             </a:pPr>
             <a:r>
-              <a:rPr lang="en-US" sz="1450" dirty="0" b="1">
+              <a:rPr lang="en-US" sz="950" dirty="0" b="1">
                 <a:solidFill>
                   <a:srgbClr val="F2F2F2"/>
                 </a:solidFill>
@@ -3737,7 +3737,7 @@
               <a:t>• מה מכריע: </a:t>
             </a:r>
             <a:r>
-              <a:rPr lang="en-US" sz="1450" dirty="0">
+              <a:rPr lang="en-US" sz="950" dirty="0">
                 <a:solidFill>
                   <a:srgbClr val="F2F2F2"/>
                 </a:solidFill>
@@ -3818,7 +3818,7 @@
               <a:buNone/>
             </a:pPr>
             <a:r>
-              <a:rPr lang="en-US" sz="1450" dirty="0" b="1">
+              <a:rPr lang="en-US" sz="800" dirty="0" b="1">
                 <a:solidFill>
                   <a:srgbClr val="F2F2F2"/>
                 </a:solidFill>
@@ -3829,7 +3829,7 @@
               <a:t>• למי להמליץ: </a:t>
             </a:r>
             <a:r>
-              <a:rPr lang="en-US" sz="1450" dirty="0">
+              <a:rPr lang="en-US" sz="800" dirty="0">
                 <a:solidFill>
                   <a:srgbClr val="F2F2F2"/>
                 </a:solidFill>
@@ -3845,7 +3845,7 @@
               <a:buNone/>
             </a:pPr>
             <a:r>
-              <a:rPr lang="en-US" sz="1450" dirty="0" b="1">
+              <a:rPr lang="en-US" sz="800" dirty="0" b="1">
                 <a:solidFill>
                   <a:srgbClr val="F2F2F2"/>
                 </a:solidFill>
@@ -3856,7 +3856,7 @@
               <a:t>• איך לפתוח: </a:t>
             </a:r>
             <a:r>
-              <a:rPr lang="en-US" sz="1450" dirty="0">
+              <a:rPr lang="en-US" sz="800" dirty="0">
                 <a:solidFill>
                   <a:srgbClr val="F2F2F2"/>
                 </a:solidFill>
@@ -3872,7 +3872,7 @@
               <a:buNone/>
             </a:pPr>
             <a:r>
-              <a:rPr lang="en-US" sz="1450" dirty="0" b="1">
+              <a:rPr lang="en-US" sz="800" dirty="0" b="1">
                 <a:solidFill>
                   <a:srgbClr val="F2F2F2"/>
                 </a:solidFill>
@@ -3883,7 +3883,7 @@
               <a:t>• מה להדגיש: </a:t>
             </a:r>
             <a:r>
-              <a:rPr lang="en-US" sz="1450" dirty="0">
+              <a:rPr lang="en-US" sz="800" dirty="0">
                 <a:solidFill>
                   <a:srgbClr val="F2F2F2"/>
                 </a:solidFill>
@@ -4638,7 +4638,7 @@
               <a:buNone/>
             </a:pPr>
             <a:r>
-              <a:rPr lang="en-US" sz="1450" dirty="0">
+              <a:rPr lang="en-US" sz="1350" dirty="0">
                 <a:solidFill>
                   <a:srgbClr val="F2F2F2"/>
                 </a:solidFill>
@@ -4654,7 +4654,7 @@
               <a:buNone/>
             </a:pPr>
             <a:r>
-              <a:rPr lang="en-US" sz="1450" dirty="0">
+              <a:rPr lang="en-US" sz="1350" dirty="0">
                 <a:solidFill>
                   <a:srgbClr val="F2F2F2"/>
                 </a:solidFill>
@@ -4670,7 +4670,7 @@
               <a:buNone/>
             </a:pPr>
             <a:r>
-              <a:rPr lang="en-US" sz="1450" dirty="0">
+              <a:rPr lang="en-US" sz="1350" dirty="0">
                 <a:solidFill>
                   <a:srgbClr val="F2F2F2"/>
                 </a:solidFill>
@@ -4792,7 +4792,7 @@
               <a:buNone/>
             </a:pPr>
             <a:r>
-              <a:rPr lang="en-US" sz="1450" dirty="0" b="1">
+              <a:rPr lang="en-US" sz="800" dirty="0" b="1">
                 <a:solidFill>
                   <a:srgbClr val="F2F2F2"/>
                 </a:solidFill>
@@ -4803,7 +4803,7 @@
               <a:t>לומר: </a:t>
             </a:r>
             <a:r>
-              <a:rPr lang="en-US" sz="1450" dirty="0">
+              <a:rPr lang="en-US" sz="800" dirty="0">
                 <a:solidFill>
                   <a:srgbClr val="F2F2F2"/>
                 </a:solidFill>
@@ -4819,7 +4819,7 @@
               <a:buNone/>
             </a:pPr>
             <a:r>
-              <a:rPr lang="en-US" sz="1450" dirty="0" b="1">
+              <a:rPr lang="en-US" sz="800" dirty="0" b="1">
                 <a:solidFill>
                   <a:srgbClr val="F2F2F2"/>
                 </a:solidFill>
@@ -4830,7 +4830,7 @@
               <a:t>לא לומר: </a:t>
             </a:r>
             <a:r>
-              <a:rPr lang="en-US" sz="1450" dirty="0">
+              <a:rPr lang="en-US" sz="800" dirty="0">
                 <a:solidFill>
                   <a:srgbClr val="F2F2F2"/>
                 </a:solidFill>
@@ -5219,7 +5219,7 @@
               <a:buNone/>
             </a:pPr>
             <a:r>
-              <a:rPr lang="en-US" sz="1450" dirty="0">
+              <a:rPr lang="en-US" sz="1150" dirty="0">
                 <a:solidFill>
                   <a:srgbClr val="F2F2F2"/>
                 </a:solidFill>
@@ -5334,7 +5334,7 @@
               <a:buNone/>
             </a:pPr>
             <a:r>
-              <a:rPr lang="en-US" sz="1450" dirty="0" b="1">
+              <a:rPr lang="en-US" sz="800" dirty="0" b="1">
                 <a:solidFill>
                   <a:srgbClr val="F2F2F2"/>
                 </a:solidFill>
@@ -5345,7 +5345,7 @@
               <a:t>הקולקציה הראשונה של Gessi שנוצרה משורשי במבוק אמיתי </a:t>
             </a:r>
             <a:r>
-              <a:rPr lang="en-US" sz="1450" dirty="0">
+              <a:rPr lang="en-US" sz="800" dirty="0">
                 <a:solidFill>
                   <a:srgbClr val="F2F2F2"/>
                 </a:solidFill>
@@ -5361,7 +5361,7 @@
               <a:buNone/>
             </a:pPr>
             <a:r>
-              <a:rPr lang="en-US" sz="1450" dirty="0" b="1">
+              <a:rPr lang="en-US" sz="800" dirty="0" b="1">
                 <a:solidFill>
                   <a:srgbClr val="F2F2F2"/>
                 </a:solidFill>
@@ -5372,7 +5372,7 @@
               <a:t>726 – Warm Bronze Br. PVD </a:t>
             </a:r>
             <a:r>
-              <a:rPr lang="en-US" sz="1450" dirty="0">
+              <a:rPr lang="en-US" sz="800" dirty="0">
                 <a:solidFill>
                   <a:srgbClr val="F2F2F2"/>
                 </a:solidFill>
@@ -5388,7 +5388,7 @@
               <a:buNone/>
             </a:pPr>
             <a:r>
-              <a:rPr lang="en-US" sz="1450" dirty="0" b="1">
+              <a:rPr lang="en-US" sz="800" dirty="0" b="1">
                 <a:solidFill>
                   <a:srgbClr val="F2F2F2"/>
                 </a:solidFill>
@@ -5399,7 +5399,7 @@
               <a:t>Low spout without waste · With connecting flexibles · Horn-effect lever · Swivel spout </a:t>
             </a:r>
             <a:r>
-              <a:rPr lang="en-US" sz="1450" dirty="0">
+              <a:rPr lang="en-US" sz="800" dirty="0">
                 <a:solidFill>
                   <a:srgbClr val="F2F2F2"/>
                 </a:solidFill>
@@ -5964,7 +5964,7 @@
               <a:buNone/>
             </a:pPr>
             <a:r>
-              <a:rPr lang="en-US" sz="1600" dirty="0">
+              <a:rPr lang="en-US" sz="1050" dirty="0">
                 <a:solidFill>
                   <a:srgbClr val="F2F2F2"/>
                 </a:solidFill>
@@ -5980,7 +5980,7 @@
               <a:buNone/>
             </a:pPr>
             <a:r>
-              <a:rPr lang="en-US" sz="1600" dirty="0">
+              <a:rPr lang="en-US" sz="1050" dirty="0">
                 <a:solidFill>
                   <a:srgbClr val="F2F2F2"/>
                 </a:solidFill>
@@ -5996,7 +5996,7 @@
               <a:buNone/>
             </a:pPr>
             <a:r>
-              <a:rPr lang="en-US" sz="1600" dirty="0">
+              <a:rPr lang="en-US" sz="1050" dirty="0">
                 <a:solidFill>
                   <a:srgbClr val="F2F2F2"/>
                 </a:solidFill>
@@ -6012,7 +6012,7 @@
               <a:buNone/>
             </a:pPr>
             <a:r>
-              <a:rPr lang="en-US" sz="1600" dirty="0">
+              <a:rPr lang="en-US" sz="1050" dirty="0">
                 <a:solidFill>
                   <a:srgbClr val="F2F2F2"/>
                 </a:solidFill>
@@ -6134,7 +6134,7 @@
               <a:buNone/>
             </a:pPr>
             <a:r>
-              <a:rPr lang="en-US" sz="1600" dirty="0" b="1">
+              <a:rPr lang="en-US" sz="900" dirty="0" b="1">
                 <a:solidFill>
                   <a:srgbClr val="F2F2F2"/>
                 </a:solidFill>
@@ -6145,7 +6145,7 @@
               <a:t>• פתיח: </a:t>
             </a:r>
             <a:r>
-              <a:rPr lang="en-US" sz="1600" dirty="0">
+              <a:rPr lang="en-US" sz="900" dirty="0">
                 <a:solidFill>
                   <a:srgbClr val="F2F2F2"/>
                 </a:solidFill>
@@ -6161,7 +6161,7 @@
               <a:buNone/>
             </a:pPr>
             <a:r>
-              <a:rPr lang="en-US" sz="1600" dirty="0" b="1">
+              <a:rPr lang="en-US" sz="900" dirty="0" b="1">
                 <a:solidFill>
                   <a:srgbClr val="F2F2F2"/>
                 </a:solidFill>
@@ -6172,7 +6172,7 @@
               <a:t>• ללקוח הפרטי: </a:t>
             </a:r>
             <a:r>
-              <a:rPr lang="en-US" sz="1600" dirty="0">
+              <a:rPr lang="en-US" sz="900" dirty="0">
                 <a:solidFill>
                   <a:srgbClr val="F2F2F2"/>
                 </a:solidFill>
@@ -6188,7 +6188,7 @@
               <a:buNone/>
             </a:pPr>
             <a:r>
-              <a:rPr lang="en-US" sz="1600" dirty="0" b="1">
+              <a:rPr lang="en-US" sz="900" dirty="0" b="1">
                 <a:solidFill>
                   <a:srgbClr val="F2F2F2"/>
                 </a:solidFill>
@@ -6199,7 +6199,7 @@
               <a:t>• לאדריכלים ומעצבים: </a:t>
             </a:r>
             <a:r>
-              <a:rPr lang="en-US" sz="1600" dirty="0">
+              <a:rPr lang="en-US" sz="900" dirty="0">
                 <a:solidFill>
                   <a:srgbClr val="F2F2F2"/>
                 </a:solidFill>
@@ -6321,7 +6321,7 @@
               <a:buNone/>
             </a:pPr>
             <a:r>
-              <a:rPr lang="en-US" sz="1600" dirty="0">
+              <a:rPr lang="en-US" sz="900" dirty="0">
                 <a:solidFill>
                   <a:srgbClr val="F2F2F2"/>
                 </a:solidFill>
@@ -6337,7 +6337,7 @@
               <a:buNone/>
             </a:pPr>
             <a:r>
-              <a:rPr lang="en-US" sz="1600" dirty="0">
+              <a:rPr lang="en-US" sz="900" dirty="0">
                 <a:solidFill>
                   <a:srgbClr val="F2F2F2"/>
                 </a:solidFill>
@@ -6353,7 +6353,7 @@
               <a:buNone/>
             </a:pPr>
             <a:r>
-              <a:rPr lang="en-US" sz="1600" dirty="0">
+              <a:rPr lang="en-US" sz="900" dirty="0">
                 <a:solidFill>
                   <a:srgbClr val="F2F2F2"/>
                 </a:solidFill>
@@ -6369,7 +6369,7 @@
               <a:buNone/>
             </a:pPr>
             <a:r>
-              <a:rPr lang="en-US" sz="1600" dirty="0" b="1">
+              <a:rPr lang="en-US" sz="900" dirty="0" b="1">
                 <a:solidFill>
                   <a:srgbClr val="F2F2F2"/>
                 </a:solidFill>
@@ -6380,7 +6380,7 @@
               <a:t>• לא להמציא: </a:t>
             </a:r>
             <a:r>
-              <a:rPr lang="en-US" sz="1600" dirty="0">
+              <a:rPr lang="en-US" sz="900" dirty="0">
                 <a:solidFill>
                   <a:srgbClr val="F2F2F2"/>
                 </a:solidFill>
@@ -6772,7 +6772,7 @@
               <a:buNone/>
             </a:pPr>
             <a:r>
-              <a:rPr lang="en-US" sz="1450" dirty="0">
+              <a:rPr lang="en-US" sz="1250" dirty="0">
                 <a:solidFill>
                   <a:srgbClr val="F2F2F2"/>
                 </a:solidFill>
@@ -6788,7 +6788,7 @@
               <a:buNone/>
             </a:pPr>
             <a:r>
-              <a:rPr lang="en-US" sz="1450" dirty="0" b="1">
+              <a:rPr lang="en-US" sz="1250" dirty="0" b="1">
                 <a:solidFill>
                   <a:srgbClr val="F2F2F2"/>
                 </a:solidFill>
@@ -6799,7 +6799,7 @@
               <a:t>סטטוס: </a:t>
             </a:r>
             <a:r>
-              <a:rPr lang="en-US" sz="1450" dirty="0">
+              <a:rPr lang="en-US" sz="1250" dirty="0">
                 <a:solidFill>
                   <a:srgbClr val="F2F2F2"/>
                 </a:solidFill>
@@ -7270,7 +7270,7 @@
               <a:buNone/>
             </a:pPr>
             <a:r>
-              <a:rPr lang="en-US" sz="1700" dirty="0">
+              <a:rPr lang="en-US" sz="950" dirty="0">
                 <a:solidFill>
                   <a:srgbClr val="F2F2F2"/>
                 </a:solidFill>

</xml_diff>